<commit_message>
Add document PDF archives and printer delivery surfaces
</commit_message>
<xml_diff>
--- a/Website/Apps/OfficeIMO.Web.Converter/wwwroot/samples/conversion-proof.pptx
+++ b/Website/Apps/OfficeIMO.Web.Converter/wwwroot/samples/conversion-proof.pptx
@@ -5,7 +5,7 @@
     <p:sldMasterId xmlns:r="http://schemas.openxmlformats.org/officeDocument/2006/relationships" id="2147483648" r:id="rId1"/>
   </p:sldMasterIdLst>
   <p:notesMasterIdLst>
-    <p:notesMasterId xmlns:r="http://schemas.openxmlformats.org/officeDocument/2006/relationships" r:id="Rc02d272637e94eba"/>
+    <p:notesMasterId xmlns:r="http://schemas.openxmlformats.org/officeDocument/2006/relationships" r:id="R4e20008eda7a480f"/>
   </p:notesMasterIdLst>
   <p:sldIdLst>
     <p:sldId xmlns:r="http://schemas.openxmlformats.org/officeDocument/2006/relationships" id="256" r:id="rId2"/>
@@ -60,6 +60,12 @@
               </c:strCache>
             </c:strRef>
           </c:tx>
+          <c:spPr>
+            <a:solidFill>
+              <a:srgbClr val="1F4E79"/>
+            </a:solidFill>
+            <a:ln/>
+          </c:spPr>
           <c:invertIfNegative val="0"/>
           <c:cat>
             <c:strRef>
@@ -102,6 +108,11 @@
               </c:numCache>
             </c:numRef>
           </c:val>
+          <c:extLst>
+            <c:ext uri="urn:officeimo:chart:auto-series-color:1">
+              <oi:autoColor xmlns:oi="urn:officeimo:chart:auto-series-color:1"/>
+            </c:ext>
+          </c:extLst>
         </c:ser>
         <c:ser>
           <c:idx val="1"/>
@@ -117,6 +128,12 @@
               </c:strCache>
             </c:strRef>
           </c:tx>
+          <c:spPr>
+            <a:solidFill>
+              <a:srgbClr val="2F6F3E"/>
+            </a:solidFill>
+            <a:ln/>
+          </c:spPr>
           <c:invertIfNegative val="0"/>
           <c:cat>
             <c:strRef>
@@ -159,6 +176,11 @@
               </c:numCache>
             </c:numRef>
           </c:val>
+          <c:extLst>
+            <c:ext uri="urn:officeimo:chart:auto-series-color:1">
+              <oi:autoColor xmlns:oi="urn:officeimo:chart:auto-series-color:1"/>
+            </c:ext>
+          </c:extLst>
         </c:ser>
         <c:dLbls>
           <c:showLegendKey val="0"/>
@@ -170,21 +192,21 @@
         </c:dLbls>
         <c:gapWidth val="150"/>
         <c:overlap val="0"/>
-        <c:axId val="48650113"/>
-        <c:axId val="48650114"/>
+        <c:axId val="48650115"/>
+        <c:axId val="48650116"/>
       </c:barChart>
       <c:catAx>
-        <c:axId val="48650113"/>
+        <c:axId val="48650115"/>
         <c:scaling>
           <c:orientation val="minMax"/>
         </c:scaling>
         <c:delete val="0"/>
         <c:axPos val="b"/>
-        <c:numFmt formatCode="General" sourceLinked="1"/>
+        <c:numFmt formatCode="General" sourceLinked="0"/>
         <c:majorTickMark val="none"/>
         <c:minorTickMark val="none"/>
         <c:tickLblPos val="nextTo"/>
-        <c:crossAx val="48650114"/>
+        <c:crossAx val="48650116"/>
         <c:crosses val="autoZero"/>
         <c:auto val="1"/>
         <c:lblAlgn val="ctr"/>
@@ -192,18 +214,18 @@
         <c:noMultiLvlLbl val="0"/>
       </c:catAx>
       <c:valAx>
-        <c:axId val="48650114"/>
+        <c:axId val="48650116"/>
         <c:scaling>
           <c:orientation val="minMax"/>
         </c:scaling>
         <c:delete val="0"/>
         <c:axPos val="l"/>
         <c:majorGridlines/>
-        <c:numFmt formatCode="General" sourceLinked="1"/>
+        <c:numFmt formatCode="General" sourceLinked="0"/>
         <c:majorTickMark val="none"/>
         <c:minorTickMark val="none"/>
         <c:tickLblPos val="nextTo"/>
-        <c:crossAx val="48650113"/>
+        <c:crossAx val="48650115"/>
         <c:crosses val="autoZero"/>
         <c:crossBetween val="between"/>
       </c:valAx>
@@ -217,7 +239,7 @@
     <c:dispBlanksAs val="gap"/>
     <c:showDLblsOverMax val="0"/>
   </c:chart>
-  <c:externalData r:id="Rb54e650b39634bfe">
+  <c:externalData r:id="R155301890f0848d1">
     <c:autoUpdate val="0"/>
   </c:externalData>
 </c:chartSpace>
@@ -2334,7 +2356,7 @@
                 </a:solidFill>
                 <a:latin typeface="Carlito"/>
               </a:rPr>
-              <a:t>12</a:t>
+              <a:t>13</a:t>
             </a:r>
           </a:p>
         </p:txBody>
@@ -2926,7 +2948,7 @@
         </p:xfrm>
         <a:graphic xmlns:a="http://schemas.openxmlformats.org/drawingml/2006/main">
           <a:graphicData uri="http://schemas.openxmlformats.org/drawingml/2006/chart">
-            <c:chart xmlns:r="http://schemas.openxmlformats.org/officeDocument/2006/relationships" xmlns:c="http://schemas.openxmlformats.org/drawingml/2006/chart" r:id="Rc5deac4b221c4ebd"/>
+            <c:chart xmlns:r="http://schemas.openxmlformats.org/officeDocument/2006/relationships" xmlns:c="http://schemas.openxmlformats.org/drawingml/2006/chart" r:id="R2ed14e46f5b64c23"/>
           </a:graphicData>
         </a:graphic>
       </p:graphicFrame>

</xml_diff>

<commit_message>
Make archive publication recoverable and wrap literal spacing safely
</commit_message>
<xml_diff>
--- a/Website/Apps/OfficeIMO.Web.Converter/wwwroot/samples/conversion-proof.pptx
+++ b/Website/Apps/OfficeIMO.Web.Converter/wwwroot/samples/conversion-proof.pptx
@@ -5,7 +5,7 @@
     <p:sldMasterId xmlns:r="http://schemas.openxmlformats.org/officeDocument/2006/relationships" id="2147483648" r:id="rId1"/>
   </p:sldMasterIdLst>
   <p:notesMasterIdLst>
-    <p:notesMasterId xmlns:r="http://schemas.openxmlformats.org/officeDocument/2006/relationships" r:id="R4e20008eda7a480f"/>
+    <p:notesMasterId xmlns:r="http://schemas.openxmlformats.org/officeDocument/2006/relationships" r:id="R60f34eebfe5343f6"/>
   </p:notesMasterIdLst>
   <p:sldIdLst>
     <p:sldId xmlns:r="http://schemas.openxmlformats.org/officeDocument/2006/relationships" id="256" r:id="rId2"/>
@@ -192,11 +192,11 @@
         </c:dLbls>
         <c:gapWidth val="150"/>
         <c:overlap val="0"/>
-        <c:axId val="48650115"/>
-        <c:axId val="48650116"/>
+        <c:axId val="48650117"/>
+        <c:axId val="48650118"/>
       </c:barChart>
       <c:catAx>
-        <c:axId val="48650115"/>
+        <c:axId val="48650117"/>
         <c:scaling>
           <c:orientation val="minMax"/>
         </c:scaling>
@@ -206,7 +206,7 @@
         <c:majorTickMark val="none"/>
         <c:minorTickMark val="none"/>
         <c:tickLblPos val="nextTo"/>
-        <c:crossAx val="48650116"/>
+        <c:crossAx val="48650118"/>
         <c:crosses val="autoZero"/>
         <c:auto val="1"/>
         <c:lblAlgn val="ctr"/>
@@ -214,7 +214,7 @@
         <c:noMultiLvlLbl val="0"/>
       </c:catAx>
       <c:valAx>
-        <c:axId val="48650116"/>
+        <c:axId val="48650118"/>
         <c:scaling>
           <c:orientation val="minMax"/>
         </c:scaling>
@@ -225,7 +225,7 @@
         <c:majorTickMark val="none"/>
         <c:minorTickMark val="none"/>
         <c:tickLblPos val="nextTo"/>
-        <c:crossAx val="48650115"/>
+        <c:crossAx val="48650117"/>
         <c:crosses val="autoZero"/>
         <c:crossBetween val="between"/>
       </c:valAx>
@@ -239,7 +239,7 @@
     <c:dispBlanksAs val="gap"/>
     <c:showDLblsOverMax val="0"/>
   </c:chart>
-  <c:externalData r:id="R155301890f0848d1">
+  <c:externalData r:id="R392c02087f6d4df4">
     <c:autoUpdate val="0"/>
   </c:externalData>
 </c:chartSpace>
@@ -2356,7 +2356,7 @@
                 </a:solidFill>
                 <a:latin typeface="Carlito"/>
               </a:rPr>
-              <a:t>13</a:t>
+              <a:t>12</a:t>
             </a:r>
           </a:p>
         </p:txBody>
@@ -2948,7 +2948,7 @@
         </p:xfrm>
         <a:graphic xmlns:a="http://schemas.openxmlformats.org/drawingml/2006/main">
           <a:graphicData uri="http://schemas.openxmlformats.org/drawingml/2006/chart">
-            <c:chart xmlns:r="http://schemas.openxmlformats.org/officeDocument/2006/relationships" xmlns:c="http://schemas.openxmlformats.org/drawingml/2006/chart" r:id="R2ed14e46f5b64c23"/>
+            <c:chart xmlns:r="http://schemas.openxmlformats.org/officeDocument/2006/relationships" xmlns:c="http://schemas.openxmlformats.org/drawingml/2006/chart" r:id="Raccf6cdff59948a7"/>
           </a:graphicData>
         </a:graphic>
       </p:graphicFrame>

</xml_diff>